<commit_message>
Lower run-cost estimate to free-tier launch; drop AI from budget
Reflect that Cardia launches on Vercel + Supabase free tiers (~$15-50/yr,
just the domain), moving to paid tiers (~$540-800/yr) only once revenue
justifies it. The AI explanation layer is out of scope for now, so it is
removed from the cost table and tech bullets in both the strategy memo and
the pitch deck.

Co-Authored-By: Claude Opus 4.8 <noreply@anthropic.com>
</commit_message>
<xml_diff>
--- a/docs/Cardia_Pitch_Deck.pptx
+++ b/docs/Cardia_Pitch_Deck.pptx
@@ -2902,27 +2902,6 @@
             </a:r>
             <a:endParaRPr lang="en-US" sz="1250" dirty="0"/>
           </a:p>
-          <a:p>
-            <a:pPr marL="342900" indent="-342900">
-              <a:spcAft>
-                <a:spcPts val="800"/>
-              </a:spcAft>
-              <a:buSzPct val="100000"/>
-              <a:buChar char="•"/>
-            </a:pPr>
-            <a:r>
-              <a:rPr lang="en-US" sz="1250" dirty="0">
-                <a:solidFill>
-                  <a:srgbClr val="44535C"/>
-                </a:solidFill>
-                <a:latin typeface="Calibri" pitchFamily="34" charset="0"/>
-                <a:ea typeface="Calibri" pitchFamily="34" charset="-122"/>
-                <a:cs typeface="Calibri" pitchFamily="34" charset="-120"/>
-              </a:rPr>
-              <a:t>Anthropic Claude  (optional AI)</a:t>
-            </a:r>
-            <a:endParaRPr lang="en-US" sz="1250" dirty="0"/>
-          </a:p>
         </p:txBody>
       </p:sp>
       <p:sp>
@@ -2958,7 +2937,7 @@
                 <a:ea typeface="Calibri" pitchFamily="34" charset="-122"/>
                 <a:cs typeface="Calibri" pitchFamily="34" charset="-120"/>
               </a:rPr>
-              <a:t>Scales to 100k+ users on the same architecture. The rules engine is free local compute; AI is the only variable cost, gated and cached.</a:t>
+              <a:t>Scales to 100k+ users on the same architecture. The clinical rules engine is free local compute, so there is no per-use cost to run a result.</a:t>
             </a:r>
             <a:endParaRPr lang="en-US" sz="1100" dirty="0"/>
           </a:p>
@@ -3168,7 +3147,7 @@
                             <a:srgbClr val="112430"/>
                           </a:solidFill>
                         </a:rPr>
-                        <a:t>Launch  (0 to 2k users)</a:t>
+                        <a:t>Launch  (free tiers)</a:t>
                       </a:r>
                       <a:endParaRPr lang="en-US" sz="1250" dirty="0"/>
                     </a:p>
@@ -3229,7 +3208,7 @@
                             <a:srgbClr val="2F7150"/>
                           </a:solidFill>
                         </a:rPr>
-                        <a:t>~$600 to 1,200</a:t>
+                        <a:t>~$15 to 50  (domain)</a:t>
                       </a:r>
                       <a:endParaRPr lang="en-US" sz="1250" dirty="0"/>
                     </a:p>
@@ -3292,7 +3271,7 @@
                             <a:srgbClr val="112430"/>
                           </a:solidFill>
                         </a:rPr>
-                        <a:t>Growth  (10 to 50k MAU)</a:t>
+                        <a:t>Growth  (paid tiers)</a:t>
                       </a:r>
                       <a:endParaRPr lang="en-US" sz="1250" dirty="0"/>
                     </a:p>
@@ -3353,7 +3332,7 @@
                             <a:srgbClr val="2F7150"/>
                           </a:solidFill>
                         </a:rPr>
-                        <a:t>~$2,000 to 8,000</a:t>
+                        <a:t>~$540 to 800</a:t>
                       </a:r>
                       <a:endParaRPr lang="en-US" sz="1250" dirty="0"/>
                     </a:p>
@@ -3414,7 +3393,7 @@
         <p:spPr>
           <a:xfrm>
             <a:off x="4343400" y="4023360"/>
-            <a:ext cx="4343400" cy="640080"/>
+            <a:ext cx="4343400" cy="731520"/>
           </a:xfrm>
           <a:prstGeom prst="rect">
             <a:avLst/>
@@ -3438,7 +3417,7 @@
                 <a:ea typeface="Calibri" pitchFamily="34" charset="-122"/>
                 <a:cs typeface="Calibri" pitchFamily="34" charset="-120"/>
               </a:rPr>
-              <a:t>Plus payment fees on revenue (2.9% + $0.30) and any marketing spend. A real product runs for under ~$1k/yr before scale.</a:t>
+              <a:t>Launches on Vercel and Supabase free tiers; you only pay for Pro tiers once revenue justifies it. Plus payment fees on revenue (2.9% + $0.30). The AI layer is out of scope, so it adds nothing to run cost.</a:t>
             </a:r>
             <a:endParaRPr lang="en-US" sz="1100" dirty="0"/>
           </a:p>
@@ -13562,7 +13541,7 @@
                 <a:ea typeface="Calibri" pitchFamily="34" charset="-122"/>
                 <a:cs typeface="Calibri" pitchFamily="34" charset="-120"/>
               </a:rPr>
-              <a:t>Rules engine, danger first UI, library, AI layer, deployed on Vercel + Supabase.</a:t>
+              <a:t>Rules engine, danger first UI, biomarker library, deployed on Vercel + Supabase.</a:t>
             </a:r>
             <a:endParaRPr lang="en-US" sz="1150" dirty="0"/>
           </a:p>
@@ -13755,7 +13734,7 @@
                 <a:ea typeface="Calibri" pitchFamily="34" charset="-122"/>
                 <a:cs typeface="Calibri" pitchFamily="34" charset="-120"/>
               </a:rPr>
-              <a:t>Accounts, Stripe billing, premium features (history, trends, PDF, AI on).</a:t>
+              <a:t>Accounts, Stripe billing, premium features (saved history, trends, doctor PDF).</a:t>
             </a:r>
             <a:endParaRPr lang="en-US" sz="1150" dirty="0"/>
           </a:p>

</xml_diff>

<commit_message>
Set realistic sellable-product run cost on paid tiers
Cardia is a product to be sold, so it runs on Vercel Pro + Supabase Pro
from day one (commercial license, daily backups, uptime) rather than free
tiers. With the AI layer out of scope, that lands at ~$555-650/yr at launch
and ~$1,000-2,400/yr at scale, below the earlier estimate. Memo explains why
free tiers are excluded; deck cost slide updated to match.

Co-Authored-By: Claude Opus 4.8 <noreply@anthropic.com>
</commit_message>
<xml_diff>
--- a/docs/Cardia_Pitch_Deck.pptx
+++ b/docs/Cardia_Pitch_Deck.pptx
@@ -3147,7 +3147,7 @@
                             <a:srgbClr val="112430"/>
                           </a:solidFill>
                         </a:rPr>
-                        <a:t>Launch  (free tiers)</a:t>
+                        <a:t>Launch  (0 to 2k users)</a:t>
                       </a:r>
                       <a:endParaRPr lang="en-US" sz="1250" dirty="0"/>
                     </a:p>
@@ -3208,7 +3208,7 @@
                             <a:srgbClr val="2F7150"/>
                           </a:solidFill>
                         </a:rPr>
-                        <a:t>~$15 to 50  (domain)</a:t>
+                        <a:t>~$555 to 650</a:t>
                       </a:r>
                       <a:endParaRPr lang="en-US" sz="1250" dirty="0"/>
                     </a:p>
@@ -3271,7 +3271,7 @@
                             <a:srgbClr val="112430"/>
                           </a:solidFill>
                         </a:rPr>
-                        <a:t>Growth  (paid tiers)</a:t>
+                        <a:t>Growth  (10 to 50k MAU)</a:t>
                       </a:r>
                       <a:endParaRPr lang="en-US" sz="1250" dirty="0"/>
                     </a:p>
@@ -3332,7 +3332,7 @@
                             <a:srgbClr val="2F7150"/>
                           </a:solidFill>
                         </a:rPr>
-                        <a:t>~$540 to 800</a:t>
+                        <a:t>~$1,000 to 2,400</a:t>
                       </a:r>
                       <a:endParaRPr lang="en-US" sz="1250" dirty="0"/>
                     </a:p>
@@ -3417,7 +3417,7 @@
                 <a:ea typeface="Calibri" pitchFamily="34" charset="-122"/>
                 <a:cs typeface="Calibri" pitchFamily="34" charset="-120"/>
               </a:rPr>
-              <a:t>Launches on Vercel and Supabase free tiers; you only pay for Pro tiers once revenue justifies it. Plus payment fees on revenue (2.9% + $0.30). The AI layer is out of scope, so it adds nothing to run cost.</a:t>
+              <a:t>Paid commercial tiers from day one (Vercel Pro + Supabase Pro), for the license, backups, and uptime a sellable product needs. Plus payment fees on revenue (2.9% + $0.30). The AI layer is out of scope, so it adds nothing to run cost.</a:t>
             </a:r>
             <a:endParaRPr lang="en-US" sz="1100" dirty="0"/>
           </a:p>

</xml_diff>